<commit_message>
Fix pitch deck slides 7, 8, and 10
Slide 10: Shift 9 checklist shapes up 0.26" — item 3 bottom now at 2.880", screenshot labels start at 2.940", 0.060" clean gap, overlap eliminated

Slide 7 (Decision + Governance): Replace right-panel screenshot with deck_activation.jpg (Activation Console) — content now matches copy

Slide 8 (Execution Orchestration): Replace right-panel screenshot with deck_test_drive.jpg (12-Minute Experience) — content now matches copy
</commit_message>
<xml_diff>
--- a/attached_assets/VaughnMartin_Pitch_Deck_12Slide_FINAL.pptx
+++ b/attached_assets/VaughnMartin_Pitch_Deck_12Slide_FINAL.pptx
@@ -3895,7 +3895,7 @@
         </p:nvSpPr>
         <p:spPr>
           <a:xfrm>
-            <a:off x="402336" y="1865376"/>
+            <a:off x="402336" y="1627632"/>
             <a:ext cx="201168" cy="201168"/>
           </a:xfrm>
           <a:prstGeom prst="ellipse">
@@ -3938,7 +3938,7 @@
         </p:nvSpPr>
         <p:spPr>
           <a:xfrm>
-            <a:off x="402336" y="1847088"/>
+            <a:off x="402336" y="1609344"/>
             <a:ext cx="201168" cy="219456"/>
           </a:xfrm>
           <a:prstGeom prst="rect">
@@ -3973,7 +3973,7 @@
         </p:nvSpPr>
         <p:spPr>
           <a:xfrm>
-            <a:off x="694944" y="1810512"/>
+            <a:off x="694944" y="1572768"/>
             <a:ext cx="6094476" cy="329184"/>
           </a:xfrm>
           <a:prstGeom prst="rect">
@@ -4008,7 +4008,7 @@
         </p:nvSpPr>
         <p:spPr>
           <a:xfrm>
-            <a:off x="402336" y="2231136"/>
+            <a:off x="402336" y="1993392"/>
             <a:ext cx="201168" cy="201168"/>
           </a:xfrm>
           <a:prstGeom prst="ellipse">
@@ -4051,7 +4051,7 @@
         </p:nvSpPr>
         <p:spPr>
           <a:xfrm>
-            <a:off x="402336" y="2212848"/>
+            <a:off x="402336" y="1975104"/>
             <a:ext cx="201168" cy="219456"/>
           </a:xfrm>
           <a:prstGeom prst="rect">
@@ -4086,7 +4086,7 @@
         </p:nvSpPr>
         <p:spPr>
           <a:xfrm>
-            <a:off x="694944" y="2176272"/>
+            <a:off x="694944" y="1938528"/>
             <a:ext cx="6094476" cy="329184"/>
           </a:xfrm>
           <a:prstGeom prst="rect">
@@ -4121,7 +4121,7 @@
         </p:nvSpPr>
         <p:spPr>
           <a:xfrm>
-            <a:off x="402336" y="2596896"/>
+            <a:off x="402336" y="2359152"/>
             <a:ext cx="201168" cy="201168"/>
           </a:xfrm>
           <a:prstGeom prst="ellipse">
@@ -4164,7 +4164,7 @@
         </p:nvSpPr>
         <p:spPr>
           <a:xfrm>
-            <a:off x="402336" y="2578608"/>
+            <a:off x="402336" y="2340864"/>
             <a:ext cx="201168" cy="219456"/>
           </a:xfrm>
           <a:prstGeom prst="rect">
@@ -4199,7 +4199,7 @@
         </p:nvSpPr>
         <p:spPr>
           <a:xfrm>
-            <a:off x="694944" y="2542032"/>
+            <a:off x="694944" y="2304288"/>
             <a:ext cx="6094476" cy="329184"/>
           </a:xfrm>
           <a:prstGeom prst="rect">
@@ -15109,9 +15109,130 @@
           </a:p>
         </p:txBody>
       </p:sp>
+      <p:sp>
+        <p:nvSpPr>
+          <p:cNvPr id="25" name="Rectangle 24"/>
+          <p:cNvSpPr/>
+          <p:nvPr/>
+        </p:nvSpPr>
+        <p:spPr>
+          <a:xfrm>
+            <a:off x="0" y="6528816"/>
+            <a:ext cx="12188952" cy="329184"/>
+          </a:xfrm>
+          <a:prstGeom prst="rect">
+            <a:avLst/>
+          </a:prstGeom>
+          <a:solidFill>
+            <a:srgbClr val="0A0F2E"/>
+          </a:solidFill>
+          <a:ln>
+            <a:noFill/>
+          </a:ln>
+        </p:spPr>
+        <p:style>
+          <a:lnRef idx="1">
+            <a:schemeClr val="accent1"/>
+          </a:lnRef>
+          <a:fillRef idx="3">
+            <a:schemeClr val="accent1"/>
+          </a:fillRef>
+          <a:effectRef idx="2">
+            <a:schemeClr val="accent1"/>
+          </a:effectRef>
+          <a:fontRef idx="minor">
+            <a:schemeClr val="lt1"/>
+          </a:fontRef>
+        </p:style>
+        <p:txBody>
+          <a:bodyPr rtlCol="0" anchor="ctr"/>
+          <a:lstStyle/>
+          <a:p>
+            <a:pPr algn="ctr"/>
+          </a:p>
+        </p:txBody>
+      </p:sp>
+      <p:sp>
+        <p:nvSpPr>
+          <p:cNvPr id="26" name="Rectangle 25"/>
+          <p:cNvSpPr/>
+          <p:nvPr/>
+        </p:nvSpPr>
+        <p:spPr>
+          <a:xfrm>
+            <a:off x="0" y="6528816"/>
+            <a:ext cx="12188952" cy="27432"/>
+          </a:xfrm>
+          <a:prstGeom prst="rect">
+            <a:avLst/>
+          </a:prstGeom>
+          <a:solidFill>
+            <a:srgbClr val="C9A84C"/>
+          </a:solidFill>
+          <a:ln>
+            <a:noFill/>
+          </a:ln>
+        </p:spPr>
+        <p:style>
+          <a:lnRef idx="1">
+            <a:schemeClr val="accent1"/>
+          </a:lnRef>
+          <a:fillRef idx="3">
+            <a:schemeClr val="accent1"/>
+          </a:fillRef>
+          <a:effectRef idx="2">
+            <a:schemeClr val="accent1"/>
+          </a:effectRef>
+          <a:fontRef idx="minor">
+            <a:schemeClr val="lt1"/>
+          </a:fontRef>
+        </p:style>
+        <p:txBody>
+          <a:bodyPr rtlCol="0" anchor="ctr"/>
+          <a:lstStyle/>
+          <a:p>
+            <a:pPr algn="ctr"/>
+          </a:p>
+        </p:txBody>
+      </p:sp>
+      <p:sp>
+        <p:nvSpPr>
+          <p:cNvPr id="27" name="TextBox 26"/>
+          <p:cNvSpPr txBox="1"/>
+          <p:nvPr/>
+        </p:nvSpPr>
+        <p:spPr>
+          <a:xfrm>
+            <a:off x="11091672" y="6592824"/>
+            <a:ext cx="914400" cy="219456"/>
+          </a:xfrm>
+          <a:prstGeom prst="rect">
+            <a:avLst/>
+          </a:prstGeom>
+          <a:noFill/>
+        </p:spPr>
+        <p:txBody>
+          <a:bodyPr wrap="square">
+            <a:spAutoFit/>
+          </a:bodyPr>
+          <a:lstStyle/>
+          <a:p>
+            <a:pPr algn="r"/>
+            <a:r>
+              <a:rPr sz="800" b="0" i="0">
+                <a:solidFill>
+                  <a:srgbClr val="9096B2"/>
+                </a:solidFill>
+                <a:latin typeface="Calibri"/>
+              </a:rPr>
+              <a:t>7  /  12</a:t>
+            </a:r>
+          </a:p>
+        </p:txBody>
+      </p:sp>
       <p:pic>
         <p:nvPicPr>
-          <p:cNvPr id="24" name="Picture 23" descr="deck_activation.jpg"/>
+          <p:cNvPr id="28" name="Picture 27" descr="image.jpg"/>
           <p:cNvPicPr>
             <a:picLocks noChangeAspect="1"/>
           </p:cNvPicPr>
@@ -15133,127 +15254,6 @@
           </a:prstGeom>
         </p:spPr>
       </p:pic>
-      <p:sp>
-        <p:nvSpPr>
-          <p:cNvPr id="25" name="Rectangle 24"/>
-          <p:cNvSpPr/>
-          <p:nvPr/>
-        </p:nvSpPr>
-        <p:spPr>
-          <a:xfrm>
-            <a:off x="0" y="6528816"/>
-            <a:ext cx="12188952" cy="329184"/>
-          </a:xfrm>
-          <a:prstGeom prst="rect">
-            <a:avLst/>
-          </a:prstGeom>
-          <a:solidFill>
-            <a:srgbClr val="0A0F2E"/>
-          </a:solidFill>
-          <a:ln>
-            <a:noFill/>
-          </a:ln>
-        </p:spPr>
-        <p:style>
-          <a:lnRef idx="1">
-            <a:schemeClr val="accent1"/>
-          </a:lnRef>
-          <a:fillRef idx="3">
-            <a:schemeClr val="accent1"/>
-          </a:fillRef>
-          <a:effectRef idx="2">
-            <a:schemeClr val="accent1"/>
-          </a:effectRef>
-          <a:fontRef idx="minor">
-            <a:schemeClr val="lt1"/>
-          </a:fontRef>
-        </p:style>
-        <p:txBody>
-          <a:bodyPr rtlCol="0" anchor="ctr"/>
-          <a:lstStyle/>
-          <a:p>
-            <a:pPr algn="ctr"/>
-          </a:p>
-        </p:txBody>
-      </p:sp>
-      <p:sp>
-        <p:nvSpPr>
-          <p:cNvPr id="26" name="Rectangle 25"/>
-          <p:cNvSpPr/>
-          <p:nvPr/>
-        </p:nvSpPr>
-        <p:spPr>
-          <a:xfrm>
-            <a:off x="0" y="6528816"/>
-            <a:ext cx="12188952" cy="27432"/>
-          </a:xfrm>
-          <a:prstGeom prst="rect">
-            <a:avLst/>
-          </a:prstGeom>
-          <a:solidFill>
-            <a:srgbClr val="C9A84C"/>
-          </a:solidFill>
-          <a:ln>
-            <a:noFill/>
-          </a:ln>
-        </p:spPr>
-        <p:style>
-          <a:lnRef idx="1">
-            <a:schemeClr val="accent1"/>
-          </a:lnRef>
-          <a:fillRef idx="3">
-            <a:schemeClr val="accent1"/>
-          </a:fillRef>
-          <a:effectRef idx="2">
-            <a:schemeClr val="accent1"/>
-          </a:effectRef>
-          <a:fontRef idx="minor">
-            <a:schemeClr val="lt1"/>
-          </a:fontRef>
-        </p:style>
-        <p:txBody>
-          <a:bodyPr rtlCol="0" anchor="ctr"/>
-          <a:lstStyle/>
-          <a:p>
-            <a:pPr algn="ctr"/>
-          </a:p>
-        </p:txBody>
-      </p:sp>
-      <p:sp>
-        <p:nvSpPr>
-          <p:cNvPr id="27" name="TextBox 26"/>
-          <p:cNvSpPr txBox="1"/>
-          <p:nvPr/>
-        </p:nvSpPr>
-        <p:spPr>
-          <a:xfrm>
-            <a:off x="11091672" y="6592824"/>
-            <a:ext cx="914400" cy="219456"/>
-          </a:xfrm>
-          <a:prstGeom prst="rect">
-            <a:avLst/>
-          </a:prstGeom>
-          <a:noFill/>
-        </p:spPr>
-        <p:txBody>
-          <a:bodyPr wrap="square">
-            <a:spAutoFit/>
-          </a:bodyPr>
-          <a:lstStyle/>
-          <a:p>
-            <a:pPr algn="r"/>
-            <a:r>
-              <a:rPr sz="800" b="0" i="0">
-                <a:solidFill>
-                  <a:srgbClr val="9096B2"/>
-                </a:solidFill>
-                <a:latin typeface="Calibri"/>
-              </a:rPr>
-              <a:t>7  /  12</a:t>
-            </a:r>
-          </a:p>
-        </p:txBody>
-      </p:sp>
     </p:spTree>
   </p:cSld>
   <p:clrMapOvr>
@@ -16143,9 +16143,130 @@
           </a:p>
         </p:txBody>
       </p:sp>
+      <p:sp>
+        <p:nvSpPr>
+          <p:cNvPr id="25" name="Rectangle 24"/>
+          <p:cNvSpPr/>
+          <p:nvPr/>
+        </p:nvSpPr>
+        <p:spPr>
+          <a:xfrm>
+            <a:off x="0" y="6528816"/>
+            <a:ext cx="12188952" cy="329184"/>
+          </a:xfrm>
+          <a:prstGeom prst="rect">
+            <a:avLst/>
+          </a:prstGeom>
+          <a:solidFill>
+            <a:srgbClr val="0A0F2E"/>
+          </a:solidFill>
+          <a:ln>
+            <a:noFill/>
+          </a:ln>
+        </p:spPr>
+        <p:style>
+          <a:lnRef idx="1">
+            <a:schemeClr val="accent1"/>
+          </a:lnRef>
+          <a:fillRef idx="3">
+            <a:schemeClr val="accent1"/>
+          </a:fillRef>
+          <a:effectRef idx="2">
+            <a:schemeClr val="accent1"/>
+          </a:effectRef>
+          <a:fontRef idx="minor">
+            <a:schemeClr val="lt1"/>
+          </a:fontRef>
+        </p:style>
+        <p:txBody>
+          <a:bodyPr rtlCol="0" anchor="ctr"/>
+          <a:lstStyle/>
+          <a:p>
+            <a:pPr algn="ctr"/>
+          </a:p>
+        </p:txBody>
+      </p:sp>
+      <p:sp>
+        <p:nvSpPr>
+          <p:cNvPr id="26" name="Rectangle 25"/>
+          <p:cNvSpPr/>
+          <p:nvPr/>
+        </p:nvSpPr>
+        <p:spPr>
+          <a:xfrm>
+            <a:off x="0" y="6528816"/>
+            <a:ext cx="12188952" cy="27432"/>
+          </a:xfrm>
+          <a:prstGeom prst="rect">
+            <a:avLst/>
+          </a:prstGeom>
+          <a:solidFill>
+            <a:srgbClr val="C9A84C"/>
+          </a:solidFill>
+          <a:ln>
+            <a:noFill/>
+          </a:ln>
+        </p:spPr>
+        <p:style>
+          <a:lnRef idx="1">
+            <a:schemeClr val="accent1"/>
+          </a:lnRef>
+          <a:fillRef idx="3">
+            <a:schemeClr val="accent1"/>
+          </a:fillRef>
+          <a:effectRef idx="2">
+            <a:schemeClr val="accent1"/>
+          </a:effectRef>
+          <a:fontRef idx="minor">
+            <a:schemeClr val="lt1"/>
+          </a:fontRef>
+        </p:style>
+        <p:txBody>
+          <a:bodyPr rtlCol="0" anchor="ctr"/>
+          <a:lstStyle/>
+          <a:p>
+            <a:pPr algn="ctr"/>
+          </a:p>
+        </p:txBody>
+      </p:sp>
+      <p:sp>
+        <p:nvSpPr>
+          <p:cNvPr id="27" name="TextBox 26"/>
+          <p:cNvSpPr txBox="1"/>
+          <p:nvPr/>
+        </p:nvSpPr>
+        <p:spPr>
+          <a:xfrm>
+            <a:off x="11091672" y="6592824"/>
+            <a:ext cx="914400" cy="219456"/>
+          </a:xfrm>
+          <a:prstGeom prst="rect">
+            <a:avLst/>
+          </a:prstGeom>
+          <a:noFill/>
+        </p:spPr>
+        <p:txBody>
+          <a:bodyPr wrap="square">
+            <a:spAutoFit/>
+          </a:bodyPr>
+          <a:lstStyle/>
+          <a:p>
+            <a:pPr algn="r"/>
+            <a:r>
+              <a:rPr sz="800" b="0" i="0">
+                <a:solidFill>
+                  <a:srgbClr val="9096B2"/>
+                </a:solidFill>
+                <a:latin typeface="Calibri"/>
+              </a:rPr>
+              <a:t>8  /  12</a:t>
+            </a:r>
+          </a:p>
+        </p:txBody>
+      </p:sp>
       <p:pic>
         <p:nvPicPr>
-          <p:cNvPr id="24" name="Picture 23" descr="slide_execution.jpg"/>
+          <p:cNvPr id="28" name="Picture 27" descr="image.jpg"/>
           <p:cNvPicPr>
             <a:picLocks noChangeAspect="1"/>
           </p:cNvPicPr>
@@ -16167,127 +16288,6 @@
           </a:prstGeom>
         </p:spPr>
       </p:pic>
-      <p:sp>
-        <p:nvSpPr>
-          <p:cNvPr id="25" name="Rectangle 24"/>
-          <p:cNvSpPr/>
-          <p:nvPr/>
-        </p:nvSpPr>
-        <p:spPr>
-          <a:xfrm>
-            <a:off x="0" y="6528816"/>
-            <a:ext cx="12188952" cy="329184"/>
-          </a:xfrm>
-          <a:prstGeom prst="rect">
-            <a:avLst/>
-          </a:prstGeom>
-          <a:solidFill>
-            <a:srgbClr val="0A0F2E"/>
-          </a:solidFill>
-          <a:ln>
-            <a:noFill/>
-          </a:ln>
-        </p:spPr>
-        <p:style>
-          <a:lnRef idx="1">
-            <a:schemeClr val="accent1"/>
-          </a:lnRef>
-          <a:fillRef idx="3">
-            <a:schemeClr val="accent1"/>
-          </a:fillRef>
-          <a:effectRef idx="2">
-            <a:schemeClr val="accent1"/>
-          </a:effectRef>
-          <a:fontRef idx="minor">
-            <a:schemeClr val="lt1"/>
-          </a:fontRef>
-        </p:style>
-        <p:txBody>
-          <a:bodyPr rtlCol="0" anchor="ctr"/>
-          <a:lstStyle/>
-          <a:p>
-            <a:pPr algn="ctr"/>
-          </a:p>
-        </p:txBody>
-      </p:sp>
-      <p:sp>
-        <p:nvSpPr>
-          <p:cNvPr id="26" name="Rectangle 25"/>
-          <p:cNvSpPr/>
-          <p:nvPr/>
-        </p:nvSpPr>
-        <p:spPr>
-          <a:xfrm>
-            <a:off x="0" y="6528816"/>
-            <a:ext cx="12188952" cy="27432"/>
-          </a:xfrm>
-          <a:prstGeom prst="rect">
-            <a:avLst/>
-          </a:prstGeom>
-          <a:solidFill>
-            <a:srgbClr val="C9A84C"/>
-          </a:solidFill>
-          <a:ln>
-            <a:noFill/>
-          </a:ln>
-        </p:spPr>
-        <p:style>
-          <a:lnRef idx="1">
-            <a:schemeClr val="accent1"/>
-          </a:lnRef>
-          <a:fillRef idx="3">
-            <a:schemeClr val="accent1"/>
-          </a:fillRef>
-          <a:effectRef idx="2">
-            <a:schemeClr val="accent1"/>
-          </a:effectRef>
-          <a:fontRef idx="minor">
-            <a:schemeClr val="lt1"/>
-          </a:fontRef>
-        </p:style>
-        <p:txBody>
-          <a:bodyPr rtlCol="0" anchor="ctr"/>
-          <a:lstStyle/>
-          <a:p>
-            <a:pPr algn="ctr"/>
-          </a:p>
-        </p:txBody>
-      </p:sp>
-      <p:sp>
-        <p:nvSpPr>
-          <p:cNvPr id="27" name="TextBox 26"/>
-          <p:cNvSpPr txBox="1"/>
-          <p:nvPr/>
-        </p:nvSpPr>
-        <p:spPr>
-          <a:xfrm>
-            <a:off x="11091672" y="6592824"/>
-            <a:ext cx="914400" cy="219456"/>
-          </a:xfrm>
-          <a:prstGeom prst="rect">
-            <a:avLst/>
-          </a:prstGeom>
-          <a:noFill/>
-        </p:spPr>
-        <p:txBody>
-          <a:bodyPr wrap="square">
-            <a:spAutoFit/>
-          </a:bodyPr>
-          <a:lstStyle/>
-          <a:p>
-            <a:pPr algn="r"/>
-            <a:r>
-              <a:rPr sz="800" b="0" i="0">
-                <a:solidFill>
-                  <a:srgbClr val="9096B2"/>
-                </a:solidFill>
-                <a:latin typeface="Calibri"/>
-              </a:rPr>
-              <a:t>8  /  12</a:t>
-            </a:r>
-          </a:p>
-        </p:txBody>
-      </p:sp>
     </p:spTree>
   </p:cSld>
   <p:clrMapOvr>

</xml_diff>

<commit_message>
Update presentation slides with live product images
Update presentation slides 5 and 6 with new screenshots of live product features and restore the original presentation file.

Replit-Commit-Author: Agent
Replit-Commit-Session-Id: 85f09f3c-352d-446d-b98e-3f307c26fc5a
Replit-Commit-Checkpoint-Type: full_checkpoint
Replit-Commit-Event-Id: ebc070aa-bfba-40a9-9fae-297b936754ee
Replit-Commit-Screenshot-Url: https://storage.googleapis.com/screenshot-production-us-central1/3bd53afc-ff4f-401b-9e3d-b367791ef629/85f09f3c-352d-446d-b98e-3f307c26fc5a/iidrAq8
Replit-Helium-Checkpoint-Created: true
</commit_message>
<xml_diff>
--- a/attached_assets/VaughnMartin_Pitch_Deck_12Slide_FINAL.pptx
+++ b/attached_assets/VaughnMartin_Pitch_Deck_12Slide_FINAL.pptx
@@ -12885,16 +12885,137 @@
           </a:p>
         </p:txBody>
       </p:sp>
+      <p:sp>
+        <p:nvSpPr>
+          <p:cNvPr id="29" name="Rectangle 28"/>
+          <p:cNvSpPr/>
+          <p:nvPr/>
+        </p:nvSpPr>
+        <p:spPr>
+          <a:xfrm>
+            <a:off x="0" y="6528816"/>
+            <a:ext cx="12188952" cy="329184"/>
+          </a:xfrm>
+          <a:prstGeom prst="rect">
+            <a:avLst/>
+          </a:prstGeom>
+          <a:solidFill>
+            <a:srgbClr val="0A0F2E"/>
+          </a:solidFill>
+          <a:ln>
+            <a:noFill/>
+          </a:ln>
+        </p:spPr>
+        <p:style>
+          <a:lnRef idx="1">
+            <a:schemeClr val="accent1"/>
+          </a:lnRef>
+          <a:fillRef idx="3">
+            <a:schemeClr val="accent1"/>
+          </a:fillRef>
+          <a:effectRef idx="2">
+            <a:schemeClr val="accent1"/>
+          </a:effectRef>
+          <a:fontRef idx="minor">
+            <a:schemeClr val="lt1"/>
+          </a:fontRef>
+        </p:style>
+        <p:txBody>
+          <a:bodyPr rtlCol="0" anchor="ctr"/>
+          <a:lstStyle/>
+          <a:p>
+            <a:pPr algn="ctr"/>
+          </a:p>
+        </p:txBody>
+      </p:sp>
+      <p:sp>
+        <p:nvSpPr>
+          <p:cNvPr id="30" name="Rectangle 29"/>
+          <p:cNvSpPr/>
+          <p:nvPr/>
+        </p:nvSpPr>
+        <p:spPr>
+          <a:xfrm>
+            <a:off x="0" y="6528816"/>
+            <a:ext cx="12188952" cy="27432"/>
+          </a:xfrm>
+          <a:prstGeom prst="rect">
+            <a:avLst/>
+          </a:prstGeom>
+          <a:solidFill>
+            <a:srgbClr val="C9A84C"/>
+          </a:solidFill>
+          <a:ln>
+            <a:noFill/>
+          </a:ln>
+        </p:spPr>
+        <p:style>
+          <a:lnRef idx="1">
+            <a:schemeClr val="accent1"/>
+          </a:lnRef>
+          <a:fillRef idx="3">
+            <a:schemeClr val="accent1"/>
+          </a:fillRef>
+          <a:effectRef idx="2">
+            <a:schemeClr val="accent1"/>
+          </a:effectRef>
+          <a:fontRef idx="minor">
+            <a:schemeClr val="lt1"/>
+          </a:fontRef>
+        </p:style>
+        <p:txBody>
+          <a:bodyPr rtlCol="0" anchor="ctr"/>
+          <a:lstStyle/>
+          <a:p>
+            <a:pPr algn="ctr"/>
+          </a:p>
+        </p:txBody>
+      </p:sp>
+      <p:sp>
+        <p:nvSpPr>
+          <p:cNvPr id="31" name="TextBox 30"/>
+          <p:cNvSpPr txBox="1"/>
+          <p:nvPr/>
+        </p:nvSpPr>
+        <p:spPr>
+          <a:xfrm>
+            <a:off x="11091672" y="6592824"/>
+            <a:ext cx="914400" cy="219456"/>
+          </a:xfrm>
+          <a:prstGeom prst="rect">
+            <a:avLst/>
+          </a:prstGeom>
+          <a:noFill/>
+        </p:spPr>
+        <p:txBody>
+          <a:bodyPr wrap="square">
+            <a:spAutoFit/>
+          </a:bodyPr>
+          <a:lstStyle/>
+          <a:p>
+            <a:pPr algn="r"/>
+            <a:r>
+              <a:rPr sz="800" b="0" i="0">
+                <a:solidFill>
+                  <a:srgbClr val="9096B2"/>
+                </a:solidFill>
+                <a:latin typeface="Calibri"/>
+              </a:rPr>
+              <a:t>5  /  12</a:t>
+            </a:r>
+          </a:p>
+        </p:txBody>
+      </p:sp>
       <p:pic>
         <p:nvPicPr>
-          <p:cNvPr id="28" name="Picture 27" descr="slide_mission_control.jpg"/>
+          <p:cNvPr id="32" name="Picture 31" descr="image.jpg"/>
           <p:cNvPicPr>
             <a:picLocks noChangeAspect="1"/>
           </p:cNvPicPr>
           <p:nvPr/>
         </p:nvPicPr>
         <p:blipFill>
-          <a:blip r:embed="rId3"/>
+          <a:blip r:embed="rId4"/>
           <a:stretch>
             <a:fillRect/>
           </a:stretch>
@@ -12909,127 +13030,6 @@
           </a:prstGeom>
         </p:spPr>
       </p:pic>
-      <p:sp>
-        <p:nvSpPr>
-          <p:cNvPr id="29" name="Rectangle 28"/>
-          <p:cNvSpPr/>
-          <p:nvPr/>
-        </p:nvSpPr>
-        <p:spPr>
-          <a:xfrm>
-            <a:off x="0" y="6528816"/>
-            <a:ext cx="12188952" cy="329184"/>
-          </a:xfrm>
-          <a:prstGeom prst="rect">
-            <a:avLst/>
-          </a:prstGeom>
-          <a:solidFill>
-            <a:srgbClr val="0A0F2E"/>
-          </a:solidFill>
-          <a:ln>
-            <a:noFill/>
-          </a:ln>
-        </p:spPr>
-        <p:style>
-          <a:lnRef idx="1">
-            <a:schemeClr val="accent1"/>
-          </a:lnRef>
-          <a:fillRef idx="3">
-            <a:schemeClr val="accent1"/>
-          </a:fillRef>
-          <a:effectRef idx="2">
-            <a:schemeClr val="accent1"/>
-          </a:effectRef>
-          <a:fontRef idx="minor">
-            <a:schemeClr val="lt1"/>
-          </a:fontRef>
-        </p:style>
-        <p:txBody>
-          <a:bodyPr rtlCol="0" anchor="ctr"/>
-          <a:lstStyle/>
-          <a:p>
-            <a:pPr algn="ctr"/>
-          </a:p>
-        </p:txBody>
-      </p:sp>
-      <p:sp>
-        <p:nvSpPr>
-          <p:cNvPr id="30" name="Rectangle 29"/>
-          <p:cNvSpPr/>
-          <p:nvPr/>
-        </p:nvSpPr>
-        <p:spPr>
-          <a:xfrm>
-            <a:off x="0" y="6528816"/>
-            <a:ext cx="12188952" cy="27432"/>
-          </a:xfrm>
-          <a:prstGeom prst="rect">
-            <a:avLst/>
-          </a:prstGeom>
-          <a:solidFill>
-            <a:srgbClr val="C9A84C"/>
-          </a:solidFill>
-          <a:ln>
-            <a:noFill/>
-          </a:ln>
-        </p:spPr>
-        <p:style>
-          <a:lnRef idx="1">
-            <a:schemeClr val="accent1"/>
-          </a:lnRef>
-          <a:fillRef idx="3">
-            <a:schemeClr val="accent1"/>
-          </a:fillRef>
-          <a:effectRef idx="2">
-            <a:schemeClr val="accent1"/>
-          </a:effectRef>
-          <a:fontRef idx="minor">
-            <a:schemeClr val="lt1"/>
-          </a:fontRef>
-        </p:style>
-        <p:txBody>
-          <a:bodyPr rtlCol="0" anchor="ctr"/>
-          <a:lstStyle/>
-          <a:p>
-            <a:pPr algn="ctr"/>
-          </a:p>
-        </p:txBody>
-      </p:sp>
-      <p:sp>
-        <p:nvSpPr>
-          <p:cNvPr id="31" name="TextBox 30"/>
-          <p:cNvSpPr txBox="1"/>
-          <p:nvPr/>
-        </p:nvSpPr>
-        <p:spPr>
-          <a:xfrm>
-            <a:off x="11091672" y="6592824"/>
-            <a:ext cx="914400" cy="219456"/>
-          </a:xfrm>
-          <a:prstGeom prst="rect">
-            <a:avLst/>
-          </a:prstGeom>
-          <a:noFill/>
-        </p:spPr>
-        <p:txBody>
-          <a:bodyPr wrap="square">
-            <a:spAutoFit/>
-          </a:bodyPr>
-          <a:lstStyle/>
-          <a:p>
-            <a:pPr algn="r"/>
-            <a:r>
-              <a:rPr sz="800" b="0" i="0">
-                <a:solidFill>
-                  <a:srgbClr val="9096B2"/>
-                </a:solidFill>
-                <a:latin typeface="Calibri"/>
-              </a:rPr>
-              <a:t>5  /  12</a:t>
-            </a:r>
-          </a:p>
-        </p:txBody>
-      </p:sp>
     </p:spTree>
   </p:cSld>
   <p:clrMapOvr>
@@ -14075,16 +14075,137 @@
           </a:p>
         </p:txBody>
       </p:sp>
+      <p:sp>
+        <p:nvSpPr>
+          <p:cNvPr id="29" name="Rectangle 28"/>
+          <p:cNvSpPr/>
+          <p:nvPr/>
+        </p:nvSpPr>
+        <p:spPr>
+          <a:xfrm>
+            <a:off x="0" y="6528816"/>
+            <a:ext cx="12188952" cy="329184"/>
+          </a:xfrm>
+          <a:prstGeom prst="rect">
+            <a:avLst/>
+          </a:prstGeom>
+          <a:solidFill>
+            <a:srgbClr val="0A0F2E"/>
+          </a:solidFill>
+          <a:ln>
+            <a:noFill/>
+          </a:ln>
+        </p:spPr>
+        <p:style>
+          <a:lnRef idx="1">
+            <a:schemeClr val="accent1"/>
+          </a:lnRef>
+          <a:fillRef idx="3">
+            <a:schemeClr val="accent1"/>
+          </a:fillRef>
+          <a:effectRef idx="2">
+            <a:schemeClr val="accent1"/>
+          </a:effectRef>
+          <a:fontRef idx="minor">
+            <a:schemeClr val="lt1"/>
+          </a:fontRef>
+        </p:style>
+        <p:txBody>
+          <a:bodyPr rtlCol="0" anchor="ctr"/>
+          <a:lstStyle/>
+          <a:p>
+            <a:pPr algn="ctr"/>
+          </a:p>
+        </p:txBody>
+      </p:sp>
+      <p:sp>
+        <p:nvSpPr>
+          <p:cNvPr id="30" name="Rectangle 29"/>
+          <p:cNvSpPr/>
+          <p:nvPr/>
+        </p:nvSpPr>
+        <p:spPr>
+          <a:xfrm>
+            <a:off x="0" y="6528816"/>
+            <a:ext cx="12188952" cy="27432"/>
+          </a:xfrm>
+          <a:prstGeom prst="rect">
+            <a:avLst/>
+          </a:prstGeom>
+          <a:solidFill>
+            <a:srgbClr val="C9A84C"/>
+          </a:solidFill>
+          <a:ln>
+            <a:noFill/>
+          </a:ln>
+        </p:spPr>
+        <p:style>
+          <a:lnRef idx="1">
+            <a:schemeClr val="accent1"/>
+          </a:lnRef>
+          <a:fillRef idx="3">
+            <a:schemeClr val="accent1"/>
+          </a:fillRef>
+          <a:effectRef idx="2">
+            <a:schemeClr val="accent1"/>
+          </a:effectRef>
+          <a:fontRef idx="minor">
+            <a:schemeClr val="lt1"/>
+          </a:fontRef>
+        </p:style>
+        <p:txBody>
+          <a:bodyPr rtlCol="0" anchor="ctr"/>
+          <a:lstStyle/>
+          <a:p>
+            <a:pPr algn="ctr"/>
+          </a:p>
+        </p:txBody>
+      </p:sp>
+      <p:sp>
+        <p:nvSpPr>
+          <p:cNvPr id="31" name="TextBox 30"/>
+          <p:cNvSpPr txBox="1"/>
+          <p:nvPr/>
+        </p:nvSpPr>
+        <p:spPr>
+          <a:xfrm>
+            <a:off x="11091672" y="6592824"/>
+            <a:ext cx="914400" cy="219456"/>
+          </a:xfrm>
+          <a:prstGeom prst="rect">
+            <a:avLst/>
+          </a:prstGeom>
+          <a:noFill/>
+        </p:spPr>
+        <p:txBody>
+          <a:bodyPr wrap="square">
+            <a:spAutoFit/>
+          </a:bodyPr>
+          <a:lstStyle/>
+          <a:p>
+            <a:pPr algn="r"/>
+            <a:r>
+              <a:rPr sz="800" b="0" i="0">
+                <a:solidFill>
+                  <a:srgbClr val="9096B2"/>
+                </a:solidFill>
+                <a:latin typeface="Calibri"/>
+              </a:rPr>
+              <a:t>6  /  12</a:t>
+            </a:r>
+          </a:p>
+        </p:txBody>
+      </p:sp>
       <p:pic>
         <p:nvPicPr>
-          <p:cNvPr id="28" name="Picture 27" descr="deck_signals.jpg"/>
+          <p:cNvPr id="32" name="Picture 31" descr="image.jpg"/>
           <p:cNvPicPr>
             <a:picLocks noChangeAspect="1"/>
           </p:cNvPicPr>
           <p:nvPr/>
         </p:nvPicPr>
         <p:blipFill>
-          <a:blip r:embed="rId3"/>
+          <a:blip r:embed="rId4"/>
           <a:stretch>
             <a:fillRect/>
           </a:stretch>
@@ -14099,127 +14220,6 @@
           </a:prstGeom>
         </p:spPr>
       </p:pic>
-      <p:sp>
-        <p:nvSpPr>
-          <p:cNvPr id="29" name="Rectangle 28"/>
-          <p:cNvSpPr/>
-          <p:nvPr/>
-        </p:nvSpPr>
-        <p:spPr>
-          <a:xfrm>
-            <a:off x="0" y="6528816"/>
-            <a:ext cx="12188952" cy="329184"/>
-          </a:xfrm>
-          <a:prstGeom prst="rect">
-            <a:avLst/>
-          </a:prstGeom>
-          <a:solidFill>
-            <a:srgbClr val="0A0F2E"/>
-          </a:solidFill>
-          <a:ln>
-            <a:noFill/>
-          </a:ln>
-        </p:spPr>
-        <p:style>
-          <a:lnRef idx="1">
-            <a:schemeClr val="accent1"/>
-          </a:lnRef>
-          <a:fillRef idx="3">
-            <a:schemeClr val="accent1"/>
-          </a:fillRef>
-          <a:effectRef idx="2">
-            <a:schemeClr val="accent1"/>
-          </a:effectRef>
-          <a:fontRef idx="minor">
-            <a:schemeClr val="lt1"/>
-          </a:fontRef>
-        </p:style>
-        <p:txBody>
-          <a:bodyPr rtlCol="0" anchor="ctr"/>
-          <a:lstStyle/>
-          <a:p>
-            <a:pPr algn="ctr"/>
-          </a:p>
-        </p:txBody>
-      </p:sp>
-      <p:sp>
-        <p:nvSpPr>
-          <p:cNvPr id="30" name="Rectangle 29"/>
-          <p:cNvSpPr/>
-          <p:nvPr/>
-        </p:nvSpPr>
-        <p:spPr>
-          <a:xfrm>
-            <a:off x="0" y="6528816"/>
-            <a:ext cx="12188952" cy="27432"/>
-          </a:xfrm>
-          <a:prstGeom prst="rect">
-            <a:avLst/>
-          </a:prstGeom>
-          <a:solidFill>
-            <a:srgbClr val="C9A84C"/>
-          </a:solidFill>
-          <a:ln>
-            <a:noFill/>
-          </a:ln>
-        </p:spPr>
-        <p:style>
-          <a:lnRef idx="1">
-            <a:schemeClr val="accent1"/>
-          </a:lnRef>
-          <a:fillRef idx="3">
-            <a:schemeClr val="accent1"/>
-          </a:fillRef>
-          <a:effectRef idx="2">
-            <a:schemeClr val="accent1"/>
-          </a:effectRef>
-          <a:fontRef idx="minor">
-            <a:schemeClr val="lt1"/>
-          </a:fontRef>
-        </p:style>
-        <p:txBody>
-          <a:bodyPr rtlCol="0" anchor="ctr"/>
-          <a:lstStyle/>
-          <a:p>
-            <a:pPr algn="ctr"/>
-          </a:p>
-        </p:txBody>
-      </p:sp>
-      <p:sp>
-        <p:nvSpPr>
-          <p:cNvPr id="31" name="TextBox 30"/>
-          <p:cNvSpPr txBox="1"/>
-          <p:nvPr/>
-        </p:nvSpPr>
-        <p:spPr>
-          <a:xfrm>
-            <a:off x="11091672" y="6592824"/>
-            <a:ext cx="914400" cy="219456"/>
-          </a:xfrm>
-          <a:prstGeom prst="rect">
-            <a:avLst/>
-          </a:prstGeom>
-          <a:noFill/>
-        </p:spPr>
-        <p:txBody>
-          <a:bodyPr wrap="square">
-            <a:spAutoFit/>
-          </a:bodyPr>
-          <a:lstStyle/>
-          <a:p>
-            <a:pPr algn="r"/>
-            <a:r>
-              <a:rPr sz="800" b="0" i="0">
-                <a:solidFill>
-                  <a:srgbClr val="9096B2"/>
-                </a:solidFill>
-                <a:latin typeface="Calibri"/>
-              </a:rPr>
-              <a:t>6  /  12</a:t>
-            </a:r>
-          </a:p>
-        </p:txBody>
-      </p:sp>
     </p:spTree>
   </p:cSld>
   <p:clrMapOvr>

</xml_diff>

<commit_message>
Update pitch deck to incorporate final presentation-ready tweaks
Update presentation slides to refine narrative, clarify scenario comparisons, and enhance call-to-action elements for improved delivery.

Replit-Commit-Author: Agent
Replit-Commit-Session-Id: 85f09f3c-352d-446d-b98e-3f307c26fc5a
Replit-Commit-Checkpoint-Type: full_checkpoint
Replit-Commit-Event-Id: 865cbf8b-b995-48c4-b0c4-ca3fb9157d29
Replit-Commit-Screenshot-Url: https://storage.googleapis.com/screenshot-production-us-central1/3bd53afc-ff4f-401b-9e3d-b367791ef629/85f09f3c-352d-446d-b98e-3f307c26fc5a/iidrAq8
Replit-Helium-Checkpoint-Created: true
</commit_message>
<xml_diff>
--- a/attached_assets/VaughnMartin_Pitch_Deck_12Slide_FINAL.pptx
+++ b/attached_assets/VaughnMartin_Pitch_Deck_12Slide_FINAL.pptx
@@ -6789,76 +6789,6 @@
       </p:sp>
       <p:sp>
         <p:nvSpPr>
-          <p:cNvPr id="14" name="TextBox 13"/>
-          <p:cNvSpPr txBox="1"/>
-          <p:nvPr/>
-        </p:nvSpPr>
-        <p:spPr>
-          <a:xfrm>
-            <a:off x="6693408" y="2651760"/>
-            <a:ext cx="4681728" cy="292608"/>
-          </a:xfrm>
-          <a:prstGeom prst="rect">
-            <a:avLst/>
-          </a:prstGeom>
-          <a:noFill/>
-        </p:spPr>
-        <p:txBody>
-          <a:bodyPr wrap="square">
-            <a:spAutoFit/>
-          </a:bodyPr>
-          <a:lstStyle/>
-          <a:p>
-            <a:pPr algn="l"/>
-            <a:r>
-              <a:rPr sz="950" b="1" i="0">
-                <a:solidFill>
-                  <a:srgbClr val="2B8A6E"/>
-                </a:solidFill>
-                <a:latin typeface="Calibri"/>
-              </a:rPr>
-              <a:t>NEXT STEP: EXECUTIVE SCENARIO SESSION</a:t>
-            </a:r>
-          </a:p>
-        </p:txBody>
-      </p:sp>
-      <p:sp>
-        <p:nvSpPr>
-          <p:cNvPr id="15" name="TextBox 14"/>
-          <p:cNvSpPr txBox="1"/>
-          <p:nvPr/>
-        </p:nvSpPr>
-        <p:spPr>
-          <a:xfrm>
-            <a:off x="6693408" y="3017520"/>
-            <a:ext cx="4681728" cy="1060704"/>
-          </a:xfrm>
-          <a:prstGeom prst="rect">
-            <a:avLst/>
-          </a:prstGeom>
-          <a:noFill/>
-        </p:spPr>
-        <p:txBody>
-          <a:bodyPr wrap="square">
-            <a:spAutoFit/>
-          </a:bodyPr>
-          <a:lstStyle/>
-          <a:p>
-            <a:pPr algn="l"/>
-            <a:r>
-              <a:rPr sz="1100" b="0" i="0">
-                <a:solidFill>
-                  <a:srgbClr val="9096B2"/>
-                </a:solidFill>
-                <a:latin typeface="Calibri"/>
-              </a:rPr>
-              <a:t>We walk your specific trigger context through Readiness OS live — signal detection through 12-minute execution.</a:t>
-            </a:r>
-          </a:p>
-        </p:txBody>
-      </p:sp>
-      <p:sp>
-        <p:nvSpPr>
           <p:cNvPr id="16" name="Rectangle 15"/>
           <p:cNvSpPr/>
           <p:nvPr/>
@@ -7122,6 +7052,353 @@
                 <a:latin typeface="Calibri"/>
               </a:rPr>
               <a:t>12  /  12</a:t>
+            </a:r>
+          </a:p>
+        </p:txBody>
+      </p:sp>
+      <p:sp>
+        <p:nvSpPr>
+          <p:cNvPr id="23" name="Rectangle 22"/>
+          <p:cNvSpPr/>
+          <p:nvPr/>
+        </p:nvSpPr>
+        <p:spPr>
+          <a:xfrm>
+            <a:off x="6291072" y="2523744"/>
+            <a:ext cx="5577840" cy="1463040"/>
+          </a:xfrm>
+          <a:prstGeom prst="rect">
+            <a:avLst/>
+          </a:prstGeom>
+          <a:solidFill>
+            <a:srgbClr val="0C1408"/>
+          </a:solidFill>
+          <a:ln>
+            <a:noFill/>
+          </a:ln>
+        </p:spPr>
+        <p:style>
+          <a:lnRef idx="1">
+            <a:schemeClr val="accent1"/>
+          </a:lnRef>
+          <a:fillRef idx="3">
+            <a:schemeClr val="accent1"/>
+          </a:fillRef>
+          <a:effectRef idx="2">
+            <a:schemeClr val="accent1"/>
+          </a:effectRef>
+          <a:fontRef idx="minor">
+            <a:schemeClr val="lt1"/>
+          </a:fontRef>
+        </p:style>
+        <p:txBody>
+          <a:bodyPr rtlCol="0" anchor="ctr"/>
+          <a:lstStyle/>
+          <a:p>
+            <a:pPr algn="ctr"/>
+          </a:p>
+        </p:txBody>
+      </p:sp>
+      <p:sp>
+        <p:nvSpPr>
+          <p:cNvPr id="24" name="Rectangle 23"/>
+          <p:cNvSpPr/>
+          <p:nvPr/>
+        </p:nvSpPr>
+        <p:spPr>
+          <a:xfrm>
+            <a:off x="6291072" y="2523744"/>
+            <a:ext cx="5577840" cy="54864"/>
+          </a:xfrm>
+          <a:prstGeom prst="rect">
+            <a:avLst/>
+          </a:prstGeom>
+          <a:solidFill>
+            <a:srgbClr val="3DBB97"/>
+          </a:solidFill>
+          <a:ln>
+            <a:noFill/>
+          </a:ln>
+        </p:spPr>
+        <p:style>
+          <a:lnRef idx="1">
+            <a:schemeClr val="accent1"/>
+          </a:lnRef>
+          <a:fillRef idx="3">
+            <a:schemeClr val="accent1"/>
+          </a:fillRef>
+          <a:effectRef idx="2">
+            <a:schemeClr val="accent1"/>
+          </a:effectRef>
+          <a:fontRef idx="minor">
+            <a:schemeClr val="lt1"/>
+          </a:fontRef>
+        </p:style>
+        <p:txBody>
+          <a:bodyPr rtlCol="0" anchor="ctr"/>
+          <a:lstStyle/>
+          <a:p>
+            <a:pPr algn="ctr"/>
+          </a:p>
+        </p:txBody>
+      </p:sp>
+      <p:sp>
+        <p:nvSpPr>
+          <p:cNvPr id="25" name="Rectangle 24"/>
+          <p:cNvSpPr/>
+          <p:nvPr/>
+        </p:nvSpPr>
+        <p:spPr>
+          <a:xfrm>
+            <a:off x="6291072" y="2523744"/>
+            <a:ext cx="54864" cy="1463040"/>
+          </a:xfrm>
+          <a:prstGeom prst="rect">
+            <a:avLst/>
+          </a:prstGeom>
+          <a:solidFill>
+            <a:srgbClr val="3DBB97"/>
+          </a:solidFill>
+          <a:ln>
+            <a:noFill/>
+          </a:ln>
+        </p:spPr>
+        <p:style>
+          <a:lnRef idx="1">
+            <a:schemeClr val="accent1"/>
+          </a:lnRef>
+          <a:fillRef idx="3">
+            <a:schemeClr val="accent1"/>
+          </a:fillRef>
+          <a:effectRef idx="2">
+            <a:schemeClr val="accent1"/>
+          </a:effectRef>
+          <a:fontRef idx="minor">
+            <a:schemeClr val="lt1"/>
+          </a:fontRef>
+        </p:style>
+        <p:txBody>
+          <a:bodyPr rtlCol="0" anchor="ctr"/>
+          <a:lstStyle/>
+          <a:p>
+            <a:pPr algn="ctr"/>
+          </a:p>
+        </p:txBody>
+      </p:sp>
+      <p:sp>
+        <p:nvSpPr>
+          <p:cNvPr id="26" name="TextBox 25"/>
+          <p:cNvSpPr txBox="1"/>
+          <p:nvPr/>
+        </p:nvSpPr>
+        <p:spPr>
+          <a:xfrm>
+            <a:off x="6437376" y="2615184"/>
+            <a:ext cx="5285232" cy="237744"/>
+          </a:xfrm>
+          <a:prstGeom prst="rect">
+            <a:avLst/>
+          </a:prstGeom>
+          <a:noFill/>
+        </p:spPr>
+        <p:txBody>
+          <a:bodyPr wrap="square">
+            <a:spAutoFit/>
+          </a:bodyPr>
+          <a:lstStyle/>
+          <a:p>
+            <a:pPr algn="l"/>
+            <a:r>
+              <a:rPr sz="900" b="1" i="0">
+                <a:solidFill>
+                  <a:srgbClr val="3DBB97"/>
+                </a:solidFill>
+                <a:latin typeface="Calibri"/>
+              </a:rPr>
+              <a:t>NEXT STEP</a:t>
+            </a:r>
+          </a:p>
+        </p:txBody>
+      </p:sp>
+      <p:sp>
+        <p:nvSpPr>
+          <p:cNvPr id="27" name="TextBox 26"/>
+          <p:cNvSpPr txBox="1"/>
+          <p:nvPr/>
+        </p:nvSpPr>
+        <p:spPr>
+          <a:xfrm>
+            <a:off x="6437376" y="2871216"/>
+            <a:ext cx="5285232" cy="475488"/>
+          </a:xfrm>
+          <a:prstGeom prst="rect">
+            <a:avLst/>
+          </a:prstGeom>
+          <a:noFill/>
+        </p:spPr>
+        <p:txBody>
+          <a:bodyPr wrap="square">
+            <a:spAutoFit/>
+          </a:bodyPr>
+          <a:lstStyle/>
+          <a:p>
+            <a:pPr algn="l"/>
+            <a:r>
+              <a:rPr sz="2200" b="1" i="0">
+                <a:solidFill>
+                  <a:srgbClr val="FFFFFF"/>
+                </a:solidFill>
+                <a:latin typeface="Georgia"/>
+              </a:rPr>
+              <a:t>Executive Scenario Session</a:t>
+            </a:r>
+          </a:p>
+        </p:txBody>
+      </p:sp>
+      <p:sp>
+        <p:nvSpPr>
+          <p:cNvPr id="28" name="TextBox 27"/>
+          <p:cNvSpPr txBox="1"/>
+          <p:nvPr/>
+        </p:nvSpPr>
+        <p:spPr>
+          <a:xfrm>
+            <a:off x="6437376" y="3364992"/>
+            <a:ext cx="5285232" cy="512064"/>
+          </a:xfrm>
+          <a:prstGeom prst="rect">
+            <a:avLst/>
+          </a:prstGeom>
+          <a:noFill/>
+        </p:spPr>
+        <p:txBody>
+          <a:bodyPr wrap="square">
+            <a:spAutoFit/>
+          </a:bodyPr>
+          <a:lstStyle/>
+          <a:p>
+            <a:pPr algn="l"/>
+            <a:r>
+              <a:rPr sz="1000" b="0" i="0">
+                <a:solidFill>
+                  <a:srgbClr val="BBCCBB"/>
+                </a:solidFill>
+                <a:latin typeface="Calibri"/>
+              </a:rPr>
+              <a:t>We walk your specific trigger context through Readiness OS live — from signal detection to 12-minute execution.</a:t>
+            </a:r>
+          </a:p>
+        </p:txBody>
+      </p:sp>
+      <p:sp>
+        <p:nvSpPr>
+          <p:cNvPr id="29" name="Rectangle 28"/>
+          <p:cNvSpPr/>
+          <p:nvPr/>
+        </p:nvSpPr>
+        <p:spPr>
+          <a:xfrm>
+            <a:off x="6437376" y="4041648"/>
+            <a:ext cx="2377440" cy="384048"/>
+          </a:xfrm>
+          <a:prstGeom prst="rect">
+            <a:avLst/>
+          </a:prstGeom>
+          <a:solidFill>
+            <a:srgbClr val="C9A84C"/>
+          </a:solidFill>
+          <a:ln>
+            <a:noFill/>
+          </a:ln>
+        </p:spPr>
+        <p:style>
+          <a:lnRef idx="1">
+            <a:schemeClr val="accent1"/>
+          </a:lnRef>
+          <a:fillRef idx="3">
+            <a:schemeClr val="accent1"/>
+          </a:fillRef>
+          <a:effectRef idx="2">
+            <a:schemeClr val="accent1"/>
+          </a:effectRef>
+          <a:fontRef idx="minor">
+            <a:schemeClr val="lt1"/>
+          </a:fontRef>
+        </p:style>
+        <p:txBody>
+          <a:bodyPr rtlCol="0" anchor="ctr"/>
+          <a:lstStyle/>
+          <a:p>
+            <a:pPr algn="ctr"/>
+          </a:p>
+        </p:txBody>
+      </p:sp>
+      <p:sp>
+        <p:nvSpPr>
+          <p:cNvPr id="30" name="TextBox 29"/>
+          <p:cNvSpPr txBox="1"/>
+          <p:nvPr/>
+        </p:nvSpPr>
+        <p:spPr>
+          <a:xfrm>
+            <a:off x="6437376" y="4096512"/>
+            <a:ext cx="2377440" cy="274320"/>
+          </a:xfrm>
+          <a:prstGeom prst="rect">
+            <a:avLst/>
+          </a:prstGeom>
+          <a:noFill/>
+        </p:spPr>
+        <p:txBody>
+          <a:bodyPr wrap="square">
+            <a:spAutoFit/>
+          </a:bodyPr>
+          <a:lstStyle/>
+          <a:p>
+            <a:pPr algn="ctr"/>
+            <a:r>
+              <a:rPr sz="950" b="1" i="0">
+                <a:solidFill>
+                  <a:srgbClr val="0A0F2E"/>
+                </a:solidFill>
+                <a:latin typeface="Calibri"/>
+              </a:rPr>
+              <a:t>REQUEST YOUR SESSION  →</a:t>
+            </a:r>
+          </a:p>
+        </p:txBody>
+      </p:sp>
+      <p:sp>
+        <p:nvSpPr>
+          <p:cNvPr id="31" name="TextBox 30"/>
+          <p:cNvSpPr txBox="1"/>
+          <p:nvPr/>
+        </p:nvSpPr>
+        <p:spPr>
+          <a:xfrm>
+            <a:off x="6437376" y="4498848"/>
+            <a:ext cx="5285232" cy="237744"/>
+          </a:xfrm>
+          <a:prstGeom prst="rect">
+            <a:avLst/>
+          </a:prstGeom>
+          <a:noFill/>
+        </p:spPr>
+        <p:txBody>
+          <a:bodyPr wrap="square">
+            <a:spAutoFit/>
+          </a:bodyPr>
+          <a:lstStyle/>
+          <a:p>
+            <a:pPr algn="l"/>
+            <a:r>
+              <a:rPr sz="900" b="0" i="0">
+                <a:solidFill>
+                  <a:srgbClr val="9096B2"/>
+                </a:solidFill>
+                <a:latin typeface="Calibri"/>
+              </a:rPr>
+              <a:t>founding@vaughnmartin.com  ·  vaughnmartin.com</a:t>
             </a:r>
           </a:p>
         </p:txBody>
@@ -10511,6 +10788,14 @@
           <a:lstStyle/>
           <a:p>
             <a:pPr algn="ctr"/>
+            <a:r>
+              <a:rPr sz="1000" b="0">
+                <a:solidFill>
+                  <a:srgbClr val="AAAFC8"/>
+                </a:solidFill>
+              </a:rPr>
+              <a:t>Define every strategic situation your organization has faced or is likely to face.</a:t>
+            </a:r>
           </a:p>
         </p:txBody>
       </p:sp>
@@ -10823,6 +11108,14 @@
           <a:lstStyle/>
           <a:p>
             <a:pPr algn="ctr"/>
+            <a:r>
+              <a:rPr sz="1000" b="0">
+                <a:solidFill>
+                  <a:srgbClr val="AAAFC8"/>
+                </a:solidFill>
+              </a:rPr>
+              <a:t>248+ data points. Customer-defined thresholds. Every 15 minutes.</a:t>
+            </a:r>
           </a:p>
         </p:txBody>
       </p:sp>
@@ -11135,6 +11428,14 @@
           <a:lstStyle/>
           <a:p>
             <a:pPr algn="ctr"/>
+            <a:r>
+              <a:rPr sz="1000" b="0">
+                <a:solidFill>
+                  <a:srgbClr val="AAAFC8"/>
+                </a:solidFill>
+              </a:rPr>
+              <a:t>Pre-assigned decision rights. Executives authorize. Execution deploys.</a:t>
+            </a:r>
           </a:p>
         </p:txBody>
       </p:sp>
@@ -11447,6 +11748,14 @@
           <a:lstStyle/>
           <a:p>
             <a:pPr algn="ctr"/>
+            <a:r>
+              <a:rPr sz="1000" b="0">
+                <a:solidFill>
+                  <a:srgbClr val="AAAFC8"/>
+                </a:solidFill>
+              </a:rPr>
+              <a:t>Roles, budgets, and communications deploy in 12 minutes.</a:t>
+            </a:r>
           </a:p>
         </p:txBody>
       </p:sp>
@@ -11759,6 +12068,14 @@
           <a:lstStyle/>
           <a:p>
             <a:pPr algn="ctr"/>
+            <a:r>
+              <a:rPr sz="1000" b="0">
+                <a:solidFill>
+                  <a:srgbClr val="AAAFC8"/>
+                </a:solidFill>
+              </a:rPr>
+              <a:t>Every activation feeds forward. Each cycle improves the next.</a:t>
+            </a:r>
           </a:p>
         </p:txBody>
       </p:sp>
@@ -13779,13 +14096,12 @@
           <a:p>
             <a:pPr algn="l"/>
             <a:r>
-              <a:rPr sz="850" b="1" i="0">
-                <a:solidFill>
-                  <a:srgbClr val="0A0F2E"/>
-                </a:solidFill>
-                <a:latin typeface="Calibri"/>
-              </a:rPr>
-              <a:t>221 TRIGGER PATTERNS</a:t>
+              <a:rPr sz="900" b="1">
+                <a:solidFill>
+                  <a:srgbClr val="C9A84C"/>
+                </a:solidFill>
+              </a:rPr>
+              <a:t>CONTINUOUS PATTERN SCORING</a:t>
             </a:r>
           </a:p>
         </p:txBody>
@@ -24266,13 +24582,12 @@
           <a:p>
             <a:pPr algn="ctr"/>
             <a:r>
-              <a:rPr sz="900" b="1" i="0">
-                <a:solidFill>
-                  <a:srgbClr val="CC2222"/>
-                </a:solidFill>
-                <a:latin typeface="Calibri"/>
-              </a:rPr>
-              <a:t>WITHOUT READINESS OS</a:t>
+              <a:rPr sz="1000" b="1">
+                <a:solidFill>
+                  <a:srgbClr val="FF6B5B"/>
+                </a:solidFill>
+              </a:rPr>
+              <a:t>✕  WITHOUT READINESS OS</a:t>
             </a:r>
           </a:p>
         </p:txBody>
@@ -24387,13 +24702,12 @@
           <a:p>
             <a:pPr algn="ctr"/>
             <a:r>
-              <a:rPr sz="900" b="1" i="0">
-                <a:solidFill>
-                  <a:srgbClr val="2B8A6E"/>
-                </a:solidFill>
-                <a:latin typeface="Calibri"/>
-              </a:rPr>
-              <a:t>WITH READINESS OS</a:t>
+              <a:rPr sz="1000" b="1">
+                <a:solidFill>
+                  <a:srgbClr val="3DBB97"/>
+                </a:solidFill>
+              </a:rPr>
+              <a:t>✓  WITH READINESS OS</a:t>
             </a:r>
           </a:p>
         </p:txBody>
@@ -25081,14 +25395,12 @@
           <a:p>
             <a:pPr algn="ctr"/>
             <a:r>
-              <a:rPr sz="800" b="1" i="0">
-                <a:solidFill>
-                  <a:srgbClr val="8A7332"/>
-                </a:solidFill>
-                <a:latin typeface="Calibri"/>
-              </a:rPr>
-              <a:t>9:59 AM →
-12 minutes</a:t>
+              <a:rPr sz="800" b="1">
+                <a:solidFill>
+                  <a:srgbClr val="FF6B5B"/>
+                </a:solidFill>
+              </a:rPr>
+              <a:t>DAY 14 →</a:t>
             </a:r>
           </a:p>
         </p:txBody>
@@ -25117,13 +25429,12 @@
           <a:p>
             <a:pPr algn="l"/>
             <a:r>
-              <a:rPr sz="1000" b="0" i="0">
-                <a:solidFill>
-                  <a:srgbClr val="CC2222"/>
-                </a:solidFill>
-                <a:latin typeface="Calibri"/>
-              </a:rPr>
-              <a:t>—</a:t>
+              <a:rPr sz="1000" b="0">
+                <a:solidFill>
+                  <a:srgbClr val="CC5544"/>
+                </a:solidFill>
+              </a:rPr>
+              <a:t>Still in alignment meetings. No coordinated response. The window has closed.</a:t>
             </a:r>
           </a:p>
         </p:txBody>
@@ -25152,13 +25463,12 @@
           <a:p>
             <a:pPr algn="l"/>
             <a:r>
-              <a:rPr sz="1000" b="1" i="0">
-                <a:solidFill>
-                  <a:srgbClr val="2B8A6E"/>
-                </a:solidFill>
-                <a:latin typeface="Calibri"/>
-              </a:rPr>
-              <a:t>Coordinated response live. Legal, IR, external counsel, board notified.</a:t>
+              <a:rPr sz="1000" b="1">
+                <a:solidFill>
+                  <a:srgbClr val="3DBB97"/>
+                </a:solidFill>
+              </a:rPr>
+              <a:t>Coordinated response live. Legal, IR, board, external counsel — all notified. 12 minutes.</a:t>
             </a:r>
           </a:p>
         </p:txBody>
@@ -25358,6 +25668,205 @@
                 <a:latin typeface="Calibri"/>
               </a:rPr>
               <a:t>9  /  12</a:t>
+            </a:r>
+          </a:p>
+        </p:txBody>
+      </p:sp>
+      <p:sp>
+        <p:nvSpPr>
+          <p:cNvPr id="40" name="Rectangle 39"/>
+          <p:cNvSpPr/>
+          <p:nvPr/>
+        </p:nvSpPr>
+        <p:spPr>
+          <a:xfrm>
+            <a:off x="5852160" y="1828800"/>
+            <a:ext cx="36576" cy="5010912"/>
+          </a:xfrm>
+          <a:prstGeom prst="rect">
+            <a:avLst/>
+          </a:prstGeom>
+          <a:solidFill>
+            <a:srgbClr val="1E284A"/>
+          </a:solidFill>
+          <a:ln>
+            <a:noFill/>
+          </a:ln>
+        </p:spPr>
+        <p:style>
+          <a:lnRef idx="1">
+            <a:schemeClr val="accent1"/>
+          </a:lnRef>
+          <a:fillRef idx="3">
+            <a:schemeClr val="accent1"/>
+          </a:fillRef>
+          <a:effectRef idx="2">
+            <a:schemeClr val="accent1"/>
+          </a:effectRef>
+          <a:fontRef idx="minor">
+            <a:schemeClr val="lt1"/>
+          </a:fontRef>
+        </p:style>
+        <p:txBody>
+          <a:bodyPr rtlCol="0" anchor="ctr"/>
+          <a:lstStyle/>
+          <a:p>
+            <a:pPr algn="ctr"/>
+          </a:p>
+        </p:txBody>
+      </p:sp>
+      <p:sp>
+        <p:nvSpPr>
+          <p:cNvPr id="41" name="Rectangle 40"/>
+          <p:cNvSpPr/>
+          <p:nvPr/>
+        </p:nvSpPr>
+        <p:spPr>
+          <a:xfrm>
+            <a:off x="402336" y="5596128"/>
+            <a:ext cx="5230368" cy="347472"/>
+          </a:xfrm>
+          <a:prstGeom prst="rect">
+            <a:avLst/>
+          </a:prstGeom>
+          <a:solidFill>
+            <a:srgbClr val="1A0606"/>
+          </a:solidFill>
+          <a:ln>
+            <a:noFill/>
+          </a:ln>
+        </p:spPr>
+        <p:style>
+          <a:lnRef idx="1">
+            <a:schemeClr val="accent1"/>
+          </a:lnRef>
+          <a:fillRef idx="3">
+            <a:schemeClr val="accent1"/>
+          </a:fillRef>
+          <a:effectRef idx="2">
+            <a:schemeClr val="accent1"/>
+          </a:effectRef>
+          <a:fontRef idx="minor">
+            <a:schemeClr val="lt1"/>
+          </a:fontRef>
+        </p:style>
+        <p:txBody>
+          <a:bodyPr rtlCol="0" anchor="ctr"/>
+          <a:lstStyle/>
+          <a:p>
+            <a:pPr algn="ctr"/>
+          </a:p>
+        </p:txBody>
+      </p:sp>
+      <p:sp>
+        <p:nvSpPr>
+          <p:cNvPr id="42" name="TextBox 41"/>
+          <p:cNvSpPr txBox="1"/>
+          <p:nvPr/>
+        </p:nvSpPr>
+        <p:spPr>
+          <a:xfrm>
+            <a:off x="548640" y="5650992"/>
+            <a:ext cx="4937760" cy="237744"/>
+          </a:xfrm>
+          <a:prstGeom prst="rect">
+            <a:avLst/>
+          </a:prstGeom>
+          <a:noFill/>
+        </p:spPr>
+        <p:txBody>
+          <a:bodyPr wrap="square">
+            <a:spAutoFit/>
+          </a:bodyPr>
+          <a:lstStyle/>
+          <a:p>
+            <a:pPr algn="l"/>
+            <a:r>
+              <a:rPr sz="950" b="1" i="0">
+                <a:solidFill>
+                  <a:srgbClr val="FF6B5B"/>
+                </a:solidFill>
+                <a:latin typeface="Calibri"/>
+              </a:rPr>
+              <a:t>30 days to mobilize — after the trigger fires</a:t>
+            </a:r>
+          </a:p>
+        </p:txBody>
+      </p:sp>
+      <p:sp>
+        <p:nvSpPr>
+          <p:cNvPr id="43" name="Rectangle 42"/>
+          <p:cNvSpPr/>
+          <p:nvPr/>
+        </p:nvSpPr>
+        <p:spPr>
+          <a:xfrm>
+            <a:off x="5888736" y="5596128"/>
+            <a:ext cx="5897880" cy="347472"/>
+          </a:xfrm>
+          <a:prstGeom prst="rect">
+            <a:avLst/>
+          </a:prstGeom>
+          <a:solidFill>
+            <a:srgbClr val="04140E"/>
+          </a:solidFill>
+          <a:ln>
+            <a:noFill/>
+          </a:ln>
+        </p:spPr>
+        <p:style>
+          <a:lnRef idx="1">
+            <a:schemeClr val="accent1"/>
+          </a:lnRef>
+          <a:fillRef idx="3">
+            <a:schemeClr val="accent1"/>
+          </a:fillRef>
+          <a:effectRef idx="2">
+            <a:schemeClr val="accent1"/>
+          </a:effectRef>
+          <a:fontRef idx="minor">
+            <a:schemeClr val="lt1"/>
+          </a:fontRef>
+        </p:style>
+        <p:txBody>
+          <a:bodyPr rtlCol="0" anchor="ctr"/>
+          <a:lstStyle/>
+          <a:p>
+            <a:pPr algn="ctr"/>
+          </a:p>
+        </p:txBody>
+      </p:sp>
+      <p:sp>
+        <p:nvSpPr>
+          <p:cNvPr id="44" name="TextBox 43"/>
+          <p:cNvSpPr txBox="1"/>
+          <p:nvPr/>
+        </p:nvSpPr>
+        <p:spPr>
+          <a:xfrm>
+            <a:off x="6035040" y="5650992"/>
+            <a:ext cx="5669280" cy="237744"/>
+          </a:xfrm>
+          <a:prstGeom prst="rect">
+            <a:avLst/>
+          </a:prstGeom>
+          <a:noFill/>
+        </p:spPr>
+        <p:txBody>
+          <a:bodyPr wrap="square">
+            <a:spAutoFit/>
+          </a:bodyPr>
+          <a:lstStyle/>
+          <a:p>
+            <a:pPr algn="l"/>
+            <a:r>
+              <a:rPr sz="950" b="1" i="0">
+                <a:solidFill>
+                  <a:srgbClr val="3DBB97"/>
+                </a:solidFill>
+                <a:latin typeface="Calibri"/>
+              </a:rPr>
+              <a:t>12 minutes — response complete, before the window closes</a:t>
             </a:r>
           </a:p>
         </p:txBody>

</xml_diff>